<commit_message>
Show the measured rapidgzip comparison in the final presentation
Replace the published 128-core figure on the third results slide with
rapidgzip 0.16.0 measured on the same machine at 1 and 10 threads.
</commit_message>
<xml_diff>
--- a/docs/final/riptide_final_presentation.pptx
+++ b/docs/final/riptide_final_presentation.pptx
@@ -2458,7 +2458,7 @@
           <a:lstStyle/>
           <a:p>
             <a:r>
-              <a:t>When an output budget turns a few large chunks into chains of continuations, splitting them brings load imbalance from 5.6 to 1.3 and makes the run 1.6 times faster. With many small chunks it makes no difference, and our header-based chunk planner did not pay off, which we report as a negative result. The rapidgzip number is from its paper on a 128-core server, so it is context, not a race.</a:t>
+              <a:t>When an output budget turns a few large chunks into chains of continuations, splitting them brings load imbalance from 5.6 to 1.3 and makes the run 1.6 times faster. With many small chunks it makes no difference, and our header-based chunk planner did not pay off, which we report as a negative result. Against rapidgzip itself, run on the same laptop, we are level at 10 threads and faster with few threads, but rapidgzip uses much less memory because it streams its output, and it is faster with small chunks, so we do not claim M3 would speed rapidgzip up without porting it.</a:t>
             </a:r>
           </a:p>
         </p:txBody>
@@ -14620,7 +14620,7 @@
                 </a:solidFill>
                 <a:latin typeface="Arial"/>
               </a:rPr>
-              <a:t>Comparison on Silesia</a:t>
+              <a:t>Against rapidgzip 0.16.0, same machine (GB/s)</a:t>
             </a:r>
           </a:p>
         </p:txBody>
@@ -14635,19 +14635,20 @@
         </p:nvGraphicFramePr>
         <p:xfrm>
           <a:off x="4572000" y="1307592"/>
-          <a:ext cx="4261104" cy="1463040"/>
+          <a:ext cx="4261104" cy="1325880"/>
         </p:xfrm>
         <a:graphic>
           <a:graphicData uri="http://schemas.openxmlformats.org/drawingml/2006/table">
             <a:tbl>
               <a:tblPr firstRow="1"/>
               <a:tblGrid>
-                <a:gridCol w="1325880"/>
-                <a:gridCol w="685800"/>
-                <a:gridCol w="960120"/>
-                <a:gridCol w="1289304"/>
+                <a:gridCol w="969264"/>
+                <a:gridCol w="822960"/>
+                <a:gridCol w="914400"/>
+                <a:gridCol w="749808"/>
+                <a:gridCol w="804672"/>
               </a:tblGrid>
-              <a:tr h="292608">
+              <a:tr h="265176">
                 <a:tc>
                   <a:txBody>
                     <a:bodyPr wrap="square"/>
@@ -14655,13 +14656,13 @@
                     <a:p>
                       <a:pPr algn="l"/>
                       <a:r>
-                        <a:rPr sz="900" b="1" i="0">
+                        <a:rPr sz="850" b="1" i="0">
                           <a:solidFill>
                             <a:srgbClr val="FFFFFF"/>
                           </a:solidFill>
                           <a:latin typeface="Arial"/>
                         </a:rPr>
-                        <a:t>System</a:t>
+                        <a:t>File</a:t>
                       </a:r>
                     </a:p>
                   </a:txBody>
@@ -14678,13 +14679,13 @@
                     <a:p>
                       <a:pPr algn="r"/>
                       <a:r>
-                        <a:rPr sz="900" b="1" i="0">
+                        <a:rPr sz="850" b="1" i="0">
                           <a:solidFill>
                             <a:srgbClr val="FFFFFF"/>
                           </a:solidFill>
                           <a:latin typeface="Arial"/>
                         </a:rPr>
-                        <a:t>Cores</a:t>
+                        <a:t>Riptide 10t</a:t>
                       </a:r>
                     </a:p>
                   </a:txBody>
@@ -14701,13 +14702,13 @@
                     <a:p>
                       <a:pPr algn="r"/>
                       <a:r>
-                        <a:rPr sz="900" b="1" i="0">
+                        <a:rPr sz="850" b="1" i="0">
                           <a:solidFill>
                             <a:srgbClr val="FFFFFF"/>
                           </a:solidFill>
                           <a:latin typeface="Arial"/>
                         </a:rPr>
-                        <a:t>Throughput</a:t>
+                        <a:t>rapidgzip 10t</a:t>
                       </a:r>
                     </a:p>
                   </a:txBody>
@@ -14722,15 +14723,38 @@
                     <a:bodyPr wrap="square"/>
                     <a:lstStyle/>
                     <a:p>
-                      <a:pPr algn="l"/>
+                      <a:pPr algn="r"/>
                       <a:r>
-                        <a:rPr sz="900" b="1" i="0">
+                        <a:rPr sz="850" b="1" i="0">
                           <a:solidFill>
                             <a:srgbClr val="FFFFFF"/>
                           </a:solidFill>
                           <a:latin typeface="Arial"/>
                         </a:rPr>
-                        <a:t>Window chain</a:t>
+                        <a:t>Riptide 1t</a:t>
+                      </a:r>
+                    </a:p>
+                  </a:txBody>
+                  <a:tcPr marL="54864" marR="54864" marT="18288" marB="18288" anchor="ctr">
+                    <a:solidFill>
+                      <a:srgbClr val="4285F4"/>
+                    </a:solidFill>
+                  </a:tcPr>
+                </a:tc>
+                <a:tc>
+                  <a:txBody>
+                    <a:bodyPr wrap="square"/>
+                    <a:lstStyle/>
+                    <a:p>
+                      <a:pPr algn="r"/>
+                      <a:r>
+                        <a:rPr sz="850" b="1" i="0">
+                          <a:solidFill>
+                            <a:srgbClr val="FFFFFF"/>
+                          </a:solidFill>
+                          <a:latin typeface="Arial"/>
+                        </a:rPr>
+                        <a:t>rapidgzip 1t</a:t>
                       </a:r>
                     </a:p>
                   </a:txBody>
@@ -14741,7 +14765,7 @@
                   </a:tcPr>
                 </a:tc>
               </a:tr>
-              <a:tr h="292608">
+              <a:tr h="265176">
                 <a:tc>
                   <a:txBody>
                     <a:bodyPr wrap="square"/>
@@ -14749,13 +14773,13 @@
                     <a:p>
                       <a:pPr algn="l"/>
                       <a:r>
-                        <a:rPr sz="900" b="0" i="0">
+                        <a:rPr sz="850" b="0" i="0">
                           <a:solidFill>
                             <a:srgbClr val="595959"/>
                           </a:solidFill>
                           <a:latin typeface="Arial"/>
                         </a:rPr>
-                        <a:t>zlib</a:t>
+                        <a:t>Silesia</a:t>
                       </a:r>
                     </a:p>
                   </a:txBody>
@@ -14772,13 +14796,13 @@
                     <a:p>
                       <a:pPr algn="r"/>
                       <a:r>
-                        <a:rPr sz="900" b="0" i="0">
+                        <a:rPr sz="850" b="0" i="0">
                           <a:solidFill>
                             <a:srgbClr val="595959"/>
                           </a:solidFill>
                           <a:latin typeface="Arial"/>
                         </a:rPr>
-                        <a:t>1</a:t>
+                        <a:t>2.33</a:t>
                       </a:r>
                     </a:p>
                   </a:txBody>
@@ -14795,13 +14819,13 @@
                     <a:p>
                       <a:pPr algn="r"/>
                       <a:r>
-                        <a:rPr sz="900" b="0" i="0">
+                        <a:rPr sz="850" b="0" i="0">
                           <a:solidFill>
                             <a:srgbClr val="595959"/>
                           </a:solidFill>
                           <a:latin typeface="Arial"/>
                         </a:rPr>
-                        <a:t>1.22 GB/s</a:t>
+                        <a:t>2.14</a:t>
                       </a:r>
                     </a:p>
                   </a:txBody>
@@ -14816,15 +14840,38 @@
                     <a:bodyPr wrap="square"/>
                     <a:lstStyle/>
                     <a:p>
-                      <a:pPr algn="l"/>
+                      <a:pPr algn="r"/>
                       <a:r>
-                        <a:rPr sz="900" b="0" i="0">
+                        <a:rPr sz="850" b="0" i="0">
                           <a:solidFill>
                             <a:srgbClr val="595959"/>
                           </a:solidFill>
                           <a:latin typeface="Arial"/>
                         </a:rPr>
-                        <a:t>—</a:t>
+                        <a:t>0.87</a:t>
+                      </a:r>
+                    </a:p>
+                  </a:txBody>
+                  <a:tcPr marL="54864" marR="54864" marT="18288" marB="18288" anchor="ctr">
+                    <a:solidFill>
+                      <a:srgbClr val="FFFFFF"/>
+                    </a:solidFill>
+                  </a:tcPr>
+                </a:tc>
+                <a:tc>
+                  <a:txBody>
+                    <a:bodyPr wrap="square"/>
+                    <a:lstStyle/>
+                    <a:p>
+                      <a:pPr algn="r"/>
+                      <a:r>
+                        <a:rPr sz="850" b="0" i="0">
+                          <a:solidFill>
+                            <a:srgbClr val="595959"/>
+                          </a:solidFill>
+                          <a:latin typeface="Arial"/>
+                        </a:rPr>
+                        <a:t>0.47</a:t>
                       </a:r>
                     </a:p>
                   </a:txBody>
@@ -14835,7 +14882,7 @@
                   </a:tcPr>
                 </a:tc>
               </a:tr>
-              <a:tr h="292608">
+              <a:tr h="265176">
                 <a:tc>
                   <a:txBody>
                     <a:bodyPr wrap="square"/>
@@ -14843,13 +14890,13 @@
                     <a:p>
                       <a:pPr algn="l"/>
                       <a:r>
-                        <a:rPr sz="900" b="0" i="0">
+                        <a:rPr sz="850" b="0" i="0">
                           <a:solidFill>
                             <a:srgbClr val="595959"/>
                           </a:solidFill>
                           <a:latin typeface="Arial"/>
                         </a:rPr>
-                        <a:t>Riptide, sequential</a:t>
+                        <a:t>Silesia ×5</a:t>
                       </a:r>
                     </a:p>
                   </a:txBody>
@@ -14866,13 +14913,13 @@
                     <a:p>
                       <a:pPr algn="r"/>
                       <a:r>
-                        <a:rPr sz="900" b="0" i="0">
+                        <a:rPr sz="850" b="0" i="0">
                           <a:solidFill>
                             <a:srgbClr val="595959"/>
                           </a:solidFill>
                           <a:latin typeface="Arial"/>
                         </a:rPr>
-                        <a:t>1</a:t>
+                        <a:t>2.50</a:t>
                       </a:r>
                     </a:p>
                   </a:txBody>
@@ -14889,155 +14936,13 @@
                     <a:p>
                       <a:pPr algn="r"/>
                       <a:r>
-                        <a:rPr sz="900" b="0" i="0">
+                        <a:rPr sz="850" b="0" i="0">
                           <a:solidFill>
                             <a:srgbClr val="595959"/>
                           </a:solidFill>
                           <a:latin typeface="Arial"/>
                         </a:rPr>
-                        <a:t>0.69 GB/s</a:t>
-                      </a:r>
-                    </a:p>
-                  </a:txBody>
-                  <a:tcPr marL="54864" marR="54864" marT="18288" marB="18288" anchor="ctr">
-                    <a:solidFill>
-                      <a:srgbClr val="F1F3F4"/>
-                    </a:solidFill>
-                  </a:tcPr>
-                </a:tc>
-                <a:tc>
-                  <a:txBody>
-                    <a:bodyPr wrap="square"/>
-                    <a:lstStyle/>
-                    <a:p>
-                      <a:pPr algn="l"/>
-                      <a:r>
-                        <a:rPr sz="900" b="0" i="0">
-                          <a:solidFill>
-                            <a:srgbClr val="595959"/>
-                          </a:solidFill>
-                          <a:latin typeface="Arial"/>
-                        </a:rPr>
-                        <a:t>—</a:t>
-                      </a:r>
-                    </a:p>
-                  </a:txBody>
-                  <a:tcPr marL="54864" marR="54864" marT="18288" marB="18288" anchor="ctr">
-                    <a:solidFill>
-                      <a:srgbClr val="F1F3F4"/>
-                    </a:solidFill>
-                  </a:tcPr>
-                </a:tc>
-              </a:tr>
-              <a:tr h="292608">
-                <a:tc>
-                  <a:txBody>
-                    <a:bodyPr wrap="square"/>
-                    <a:lstStyle/>
-                    <a:p>
-                      <a:pPr algn="l"/>
-                      <a:r>
-                        <a:rPr sz="900" b="1" i="0">
-                          <a:solidFill>
-                            <a:srgbClr val="212121"/>
-                          </a:solidFill>
-                          <a:latin typeface="Arial"/>
-                        </a:rPr>
-                        <a:t>Riptide</a:t>
-                      </a:r>
-                    </a:p>
-                  </a:txBody>
-                  <a:tcPr marL="54864" marR="54864" marT="18288" marB="18288" anchor="ctr">
-                    <a:solidFill>
-                      <a:srgbClr val="E8F0FE"/>
-                    </a:solidFill>
-                  </a:tcPr>
-                </a:tc>
-                <a:tc>
-                  <a:txBody>
-                    <a:bodyPr wrap="square"/>
-                    <a:lstStyle/>
-                    <a:p>
-                      <a:pPr algn="r"/>
-                      <a:r>
-                        <a:rPr sz="900" b="1" i="0">
-                          <a:solidFill>
-                            <a:srgbClr val="212121"/>
-                          </a:solidFill>
-                          <a:latin typeface="Arial"/>
-                        </a:rPr>
-                        <a:t>10</a:t>
-                      </a:r>
-                    </a:p>
-                  </a:txBody>
-                  <a:tcPr marL="54864" marR="54864" marT="18288" marB="18288" anchor="ctr">
-                    <a:solidFill>
-                      <a:srgbClr val="E8F0FE"/>
-                    </a:solidFill>
-                  </a:tcPr>
-                </a:tc>
-                <a:tc>
-                  <a:txBody>
-                    <a:bodyPr wrap="square"/>
-                    <a:lstStyle/>
-                    <a:p>
-                      <a:pPr algn="r"/>
-                      <a:r>
-                        <a:rPr sz="900" b="1" i="0">
-                          <a:solidFill>
-                            <a:srgbClr val="212121"/>
-                          </a:solidFill>
-                          <a:latin typeface="Arial"/>
-                        </a:rPr>
-                        <a:t>2.60 GB/s</a:t>
-                      </a:r>
-                    </a:p>
-                  </a:txBody>
-                  <a:tcPr marL="54864" marR="54864" marT="18288" marB="18288" anchor="ctr">
-                    <a:solidFill>
-                      <a:srgbClr val="E8F0FE"/>
-                    </a:solidFill>
-                  </a:tcPr>
-                </a:tc>
-                <a:tc>
-                  <a:txBody>
-                    <a:bodyPr wrap="square"/>
-                    <a:lstStyle/>
-                    <a:p>
-                      <a:pPr algn="l"/>
-                      <a:r>
-                        <a:rPr sz="900" b="1" i="0">
-                          <a:solidFill>
-                            <a:srgbClr val="212121"/>
-                          </a:solidFill>
-                          <a:latin typeface="Arial"/>
-                        </a:rPr>
-                        <a:t>prefix scan</a:t>
-                      </a:r>
-                    </a:p>
-                  </a:txBody>
-                  <a:tcPr marL="54864" marR="54864" marT="18288" marB="18288" anchor="ctr">
-                    <a:solidFill>
-                      <a:srgbClr val="E8F0FE"/>
-                    </a:solidFill>
-                  </a:tcPr>
-                </a:tc>
-              </a:tr>
-              <a:tr h="292608">
-                <a:tc>
-                  <a:txBody>
-                    <a:bodyPr wrap="square"/>
-                    <a:lstStyle/>
-                    <a:p>
-                      <a:pPr algn="l"/>
-                      <a:r>
-                        <a:rPr sz="900" b="0" i="0">
-                          <a:solidFill>
-                            <a:srgbClr val="595959"/>
-                          </a:solidFill>
-                          <a:latin typeface="Arial"/>
-                        </a:rPr>
-                        <a:t>rapidgzip*</a:t>
+                        <a:t>2.16</a:t>
                       </a:r>
                     </a:p>
                   </a:txBody>
@@ -15054,13 +14959,13 @@
                     <a:p>
                       <a:pPr algn="r"/>
                       <a:r>
-                        <a:rPr sz="900" b="0" i="0">
+                        <a:rPr sz="850" b="0" i="0">
                           <a:solidFill>
                             <a:srgbClr val="595959"/>
                           </a:solidFill>
                           <a:latin typeface="Arial"/>
                         </a:rPr>
-                        <a:t>128</a:t>
+                        <a:t>0.86</a:t>
                       </a:r>
                     </a:p>
                   </a:txBody>
@@ -15077,13 +14982,155 @@
                     <a:p>
                       <a:pPr algn="r"/>
                       <a:r>
-                        <a:rPr sz="900" b="0" i="0">
+                        <a:rPr sz="850" b="0" i="0">
                           <a:solidFill>
                             <a:srgbClr val="595959"/>
                           </a:solidFill>
                           <a:latin typeface="Arial"/>
                         </a:rPr>
-                        <a:t>5.6 GB/s</a:t>
+                        <a:t>0.46</a:t>
+                      </a:r>
+                    </a:p>
+                  </a:txBody>
+                  <a:tcPr marL="54864" marR="54864" marT="18288" marB="18288" anchor="ctr">
+                    <a:solidFill>
+                      <a:srgbClr val="F1F3F4"/>
+                    </a:solidFill>
+                  </a:tcPr>
+                </a:tc>
+              </a:tr>
+              <a:tr h="265176">
+                <a:tc>
+                  <a:txBody>
+                    <a:bodyPr wrap="square"/>
+                    <a:lstStyle/>
+                    <a:p>
+                      <a:pPr algn="l"/>
+                      <a:r>
+                        <a:rPr sz="850" b="0" i="0">
+                          <a:solidFill>
+                            <a:srgbClr val="595959"/>
+                          </a:solidFill>
+                          <a:latin typeface="Arial"/>
+                        </a:rPr>
+                        <a:t>FASTQ</a:t>
+                      </a:r>
+                    </a:p>
+                  </a:txBody>
+                  <a:tcPr marL="54864" marR="54864" marT="18288" marB="18288" anchor="ctr">
+                    <a:solidFill>
+                      <a:srgbClr val="FFFFFF"/>
+                    </a:solidFill>
+                  </a:tcPr>
+                </a:tc>
+                <a:tc>
+                  <a:txBody>
+                    <a:bodyPr wrap="square"/>
+                    <a:lstStyle/>
+                    <a:p>
+                      <a:pPr algn="r"/>
+                      <a:r>
+                        <a:rPr sz="850" b="0" i="0">
+                          <a:solidFill>
+                            <a:srgbClr val="595959"/>
+                          </a:solidFill>
+                          <a:latin typeface="Arial"/>
+                        </a:rPr>
+                        <a:t>1.99</a:t>
+                      </a:r>
+                    </a:p>
+                  </a:txBody>
+                  <a:tcPr marL="54864" marR="54864" marT="18288" marB="18288" anchor="ctr">
+                    <a:solidFill>
+                      <a:srgbClr val="FFFFFF"/>
+                    </a:solidFill>
+                  </a:tcPr>
+                </a:tc>
+                <a:tc>
+                  <a:txBody>
+                    <a:bodyPr wrap="square"/>
+                    <a:lstStyle/>
+                    <a:p>
+                      <a:pPr algn="r"/>
+                      <a:r>
+                        <a:rPr sz="850" b="0" i="0">
+                          <a:solidFill>
+                            <a:srgbClr val="595959"/>
+                          </a:solidFill>
+                          <a:latin typeface="Arial"/>
+                        </a:rPr>
+                        <a:t>2.03</a:t>
+                      </a:r>
+                    </a:p>
+                  </a:txBody>
+                  <a:tcPr marL="54864" marR="54864" marT="18288" marB="18288" anchor="ctr">
+                    <a:solidFill>
+                      <a:srgbClr val="FFFFFF"/>
+                    </a:solidFill>
+                  </a:tcPr>
+                </a:tc>
+                <a:tc>
+                  <a:txBody>
+                    <a:bodyPr wrap="square"/>
+                    <a:lstStyle/>
+                    <a:p>
+                      <a:pPr algn="r"/>
+                      <a:r>
+                        <a:rPr sz="850" b="0" i="0">
+                          <a:solidFill>
+                            <a:srgbClr val="595959"/>
+                          </a:solidFill>
+                          <a:latin typeface="Arial"/>
+                        </a:rPr>
+                        <a:t>0.66</a:t>
+                      </a:r>
+                    </a:p>
+                  </a:txBody>
+                  <a:tcPr marL="54864" marR="54864" marT="18288" marB="18288" anchor="ctr">
+                    <a:solidFill>
+                      <a:srgbClr val="FFFFFF"/>
+                    </a:solidFill>
+                  </a:tcPr>
+                </a:tc>
+                <a:tc>
+                  <a:txBody>
+                    <a:bodyPr wrap="square"/>
+                    <a:lstStyle/>
+                    <a:p>
+                      <a:pPr algn="r"/>
+                      <a:r>
+                        <a:rPr sz="850" b="0" i="0">
+                          <a:solidFill>
+                            <a:srgbClr val="595959"/>
+                          </a:solidFill>
+                          <a:latin typeface="Arial"/>
+                        </a:rPr>
+                        <a:t>0.54</a:t>
+                      </a:r>
+                    </a:p>
+                  </a:txBody>
+                  <a:tcPr marL="54864" marR="54864" marT="18288" marB="18288" anchor="ctr">
+                    <a:solidFill>
+                      <a:srgbClr val="FFFFFF"/>
+                    </a:solidFill>
+                  </a:tcPr>
+                </a:tc>
+              </a:tr>
+              <a:tr h="265176">
+                <a:tc>
+                  <a:txBody>
+                    <a:bodyPr wrap="square"/>
+                    <a:lstStyle/>
+                    <a:p>
+                      <a:pPr algn="l"/>
+                      <a:r>
+                        <a:rPr sz="850" b="0" i="0">
+                          <a:solidFill>
+                            <a:srgbClr val="595959"/>
+                          </a:solidFill>
+                          <a:latin typeface="Arial"/>
+                        </a:rPr>
+                        <a:t>Logs</a:t>
                       </a:r>
                     </a:p>
                   </a:txBody>
@@ -15098,15 +15145,84 @@
                     <a:bodyPr wrap="square"/>
                     <a:lstStyle/>
                     <a:p>
-                      <a:pPr algn="l"/>
+                      <a:pPr algn="r"/>
                       <a:r>
-                        <a:rPr sz="900" b="0" i="0">
+                        <a:rPr sz="850" b="0" i="0">
                           <a:solidFill>
                             <a:srgbClr val="595959"/>
                           </a:solidFill>
                           <a:latin typeface="Arial"/>
                         </a:rPr>
-                        <a:t>serial</a:t>
+                        <a:t>4.21</a:t>
+                      </a:r>
+                    </a:p>
+                  </a:txBody>
+                  <a:tcPr marL="54864" marR="54864" marT="18288" marB="18288" anchor="ctr">
+                    <a:solidFill>
+                      <a:srgbClr val="F1F3F4"/>
+                    </a:solidFill>
+                  </a:tcPr>
+                </a:tc>
+                <a:tc>
+                  <a:txBody>
+                    <a:bodyPr wrap="square"/>
+                    <a:lstStyle/>
+                    <a:p>
+                      <a:pPr algn="r"/>
+                      <a:r>
+                        <a:rPr sz="850" b="0" i="0">
+                          <a:solidFill>
+                            <a:srgbClr val="595959"/>
+                          </a:solidFill>
+                          <a:latin typeface="Arial"/>
+                        </a:rPr>
+                        <a:t>4.61</a:t>
+                      </a:r>
+                    </a:p>
+                  </a:txBody>
+                  <a:tcPr marL="54864" marR="54864" marT="18288" marB="18288" anchor="ctr">
+                    <a:solidFill>
+                      <a:srgbClr val="F1F3F4"/>
+                    </a:solidFill>
+                  </a:tcPr>
+                </a:tc>
+                <a:tc>
+                  <a:txBody>
+                    <a:bodyPr wrap="square"/>
+                    <a:lstStyle/>
+                    <a:p>
+                      <a:pPr algn="r"/>
+                      <a:r>
+                        <a:rPr sz="850" b="0" i="0">
+                          <a:solidFill>
+                            <a:srgbClr val="595959"/>
+                          </a:solidFill>
+                          <a:latin typeface="Arial"/>
+                        </a:rPr>
+                        <a:t>1.75</a:t>
+                      </a:r>
+                    </a:p>
+                  </a:txBody>
+                  <a:tcPr marL="54864" marR="54864" marT="18288" marB="18288" anchor="ctr">
+                    <a:solidFill>
+                      <a:srgbClr val="F1F3F4"/>
+                    </a:solidFill>
+                  </a:tcPr>
+                </a:tc>
+                <a:tc>
+                  <a:txBody>
+                    <a:bodyPr wrap="square"/>
+                    <a:lstStyle/>
+                    <a:p>
+                      <a:pPr algn="r"/>
+                      <a:r>
+                        <a:rPr sz="850" b="0" i="0">
+                          <a:solidFill>
+                            <a:srgbClr val="595959"/>
+                          </a:solidFill>
+                          <a:latin typeface="Arial"/>
+                        </a:rPr>
+                        <a:t>1.78</a:t>
                       </a:r>
                     </a:p>
                   </a:txBody>
@@ -15129,8 +15245,8 @@
         </p:nvSpPr>
         <p:spPr>
           <a:xfrm>
-            <a:off x="4572000" y="2816352"/>
-            <a:ext cx="4261104" cy="457200"/>
+            <a:off x="4572000" y="2679192"/>
+            <a:ext cx="4261104" cy="685800"/>
           </a:xfrm>
           <a:prstGeom prst="rect">
             <a:avLst/>
@@ -15151,7 +15267,7 @@
                 </a:solidFill>
                 <a:latin typeface="Arial"/>
               </a:rPr>
-              <a:t>* Published by the base paper on 128 AMD EPYC cores; not run by us, so not directly comparable.</a:t>
+              <a:t>10 threads: no significant difference (0.91–1.16×). 1–2 threads: Riptide 1.2–1.9× faster (rapidgzip has no ISA-L on ARM). rapidgzip needs 2–5× less memory and is 1.3× faster with 64 KiB chunks.</a:t>
             </a:r>
           </a:p>
         </p:txBody>

</xml_diff>

<commit_message>
Carry the rapidgzip comparison through the final presentation
State on the window-resolution slide that rapidgzip is still faster with
64 KiB chunks, add the comparison to the achievements and conclusion,
and update the project status and speaker notes.
</commit_message>
<xml_diff>
--- a/docs/final/riptide_final_presentation.pptx
+++ b/docs/final/riptide_final_presentation.pptx
@@ -2253,7 +2253,7 @@
           <a:lstStyle/>
           <a:p>
             <a:r>
-              <a:t>Everything on the slide is our own code and our own measurements. The bugs we list are the ones that cost us most time: the race only showed up in one run in eight, and the memory problem only appeared on gigabyte-sized inputs.</a:t>
+              <a:t>Everything on the slide is our own code and our own measurements. The bugs we list are the ones that cost us most time: the race only showed up in one run in eight, and the memory problem only appeared on gigabyte-sized inputs. We also ran rapidgzip, the base paper's own tool, on the same laptop: at 10 threads the two are statistically level.</a:t>
             </a:r>
           </a:p>
         </p:txBody>
@@ -2342,7 +2342,7 @@
           <a:lstStyle/>
           <a:p>
             <a:r>
-              <a:t>Our claim is narrow and measured: the base paper's serial step parallelises, and it pays off exactly when chunks are small. The next step is to put the scan into rapidgzip and test it on the core counts where the base paper stops scaling.</a:t>
+              <a:t>Our claim is narrow and measured: the base paper's serial step parallelises, and it pays off exactly when chunks are small. Against the base paper's own tool we are level at 10 threads, and we name where it is still better: memory and small chunks. The next steps are streaming output, which closes the memory gap, and putting the scan into rapidgzip on the core counts where it stops scaling.</a:t>
             </a:r>
           </a:p>
         </p:txBody>
@@ -2400,7 +2400,7 @@
           <a:lstStyle/>
           <a:p>
             <a:r>
-              <a:t>This is the main result. The blocked scan resolves the windows three to four times faster than the serial chain at every chunk size, and it keeps getting faster with more cores while the chain does not. It matters for the whole run when chunks are small, which is also when memory use is lowest. With large chunks the chain was already cheap, and we report that too.</a:t>
+              <a:t>This is the main result. The blocked scan resolves the windows three to four times faster than the serial chain at every chunk size, and it keeps getting faster with more cores while the chain does not. It matters for the whole run when chunks are small, which is also when memory use is lowest. Two limits we state ourselves: with large chunks the chain was already cheap, and with 64 KiB chunks rapidgzip is still faster than our whole decoder, because our block search and per-chunk bookkeeping cost more than theirs. So M3 is proven inside Riptide; inside rapidgzip it is future work.</a:t>
             </a:r>
           </a:p>
         </p:txBody>
@@ -12947,7 +12947,7 @@
                 <a:spcPct val="108000"/>
               </a:lnSpc>
               <a:spcAft>
-                <a:spcPts val="700"/>
+                <a:spcPts val="500"/>
               </a:spcAft>
               <a:buClr>
                 <a:srgbClr val="4285F4"/>
@@ -12956,7 +12956,7 @@
               <a:buChar char="•"/>
             </a:pPr>
             <a:r>
-              <a:rPr sz="1000" b="1" i="0">
+              <a:rPr sz="950" b="1" i="0">
                 <a:solidFill>
                   <a:srgbClr val="212121"/>
                 </a:solidFill>
@@ -12965,7 +12965,7 @@
               <a:t>A complete parallel gzip decoder from scratch: </a:t>
             </a:r>
             <a:r>
-              <a:rPr sz="1000" b="0" i="0">
+              <a:rPr sz="950" b="0" i="0">
                 <a:solidFill>
                   <a:srgbClr val="595959"/>
                 </a:solidFill>
@@ -12980,7 +12980,7 @@
                 <a:spcPct val="108000"/>
               </a:lnSpc>
               <a:spcAft>
-                <a:spcPts val="700"/>
+                <a:spcPts val="500"/>
               </a:spcAft>
               <a:buClr>
                 <a:srgbClr val="4285F4"/>
@@ -12989,7 +12989,7 @@
               <a:buChar char="•"/>
             </a:pPr>
             <a:r>
-              <a:rPr sz="1000" b="1" i="0">
+              <a:rPr sz="950" b="1" i="0">
                 <a:solidFill>
                   <a:srgbClr val="212121"/>
                 </a:solidFill>
@@ -12998,7 +12998,7 @@
               <a:t>M3 and M1 implemented and evaluated </a:t>
             </a:r>
             <a:r>
-              <a:rPr sz="1000" b="0" i="0">
+              <a:rPr sz="950" b="0" i="0">
                 <a:solidFill>
                   <a:srgbClr val="595959"/>
                 </a:solidFill>
@@ -13013,7 +13013,7 @@
                 <a:spcPct val="108000"/>
               </a:lnSpc>
               <a:spcAft>
-                <a:spcPts val="700"/>
+                <a:spcPts val="500"/>
               </a:spcAft>
               <a:buClr>
                 <a:srgbClr val="4285F4"/>
@@ -13022,7 +13022,7 @@
               <a:buChar char="•"/>
             </a:pPr>
             <a:r>
-              <a:rPr sz="1000" b="1" i="0">
+              <a:rPr sz="950" b="1" i="0">
                 <a:solidFill>
                   <a:srgbClr val="212121"/>
                 </a:solidFill>
@@ -13031,7 +13031,7 @@
               <a:t>Hard problems solved: </a:t>
             </a:r>
             <a:r>
-              <a:rPr sz="1000" b="0" i="0">
+              <a:rPr sz="950" b="0" i="0">
                 <a:solidFill>
                   <a:srgbClr val="595959"/>
                 </a:solidFill>
@@ -13046,7 +13046,7 @@
                 <a:spcPct val="108000"/>
               </a:lnSpc>
               <a:spcAft>
-                <a:spcPts val="700"/>
+                <a:spcPts val="500"/>
               </a:spcAft>
               <a:buClr>
                 <a:srgbClr val="4285F4"/>
@@ -13055,7 +13055,40 @@
               <a:buChar char="•"/>
             </a:pPr>
             <a:r>
-              <a:rPr sz="1000" b="1" i="0">
+              <a:rPr sz="950" b="1" i="0">
+                <a:solidFill>
+                  <a:srgbClr val="212121"/>
+                </a:solidFill>
+                <a:latin typeface="Arial"/>
+              </a:rPr>
+              <a:t>Benchmarked against the base paper's software: </a:t>
+            </a:r>
+            <a:r>
+              <a:rPr sz="950" b="0" i="0">
+                <a:solidFill>
+                  <a:srgbClr val="595959"/>
+                </a:solidFill>
+                <a:latin typeface="Arial"/>
+              </a:rPr>
+              <a:t>level with rapidgzip at 10 threads, 1.2–1.9× faster with 1–2 threads.</a:t>
+            </a:r>
+          </a:p>
+          <a:p>
+            <a:pPr marL="164592" indent="-164592">
+              <a:lnSpc>
+                <a:spcPct val="108000"/>
+              </a:lnSpc>
+              <a:spcAft>
+                <a:spcPts val="500"/>
+              </a:spcAft>
+              <a:buClr>
+                <a:srgbClr val="4285F4"/>
+              </a:buClr>
+              <a:buFont typeface="Arial"/>
+              <a:buChar char="•"/>
+            </a:pPr>
+            <a:r>
+              <a:rPr sz="950" b="1" i="0">
                 <a:solidFill>
                   <a:srgbClr val="212121"/>
                 </a:solidFill>
@@ -13064,13 +13097,13 @@
               <a:t>Quality: </a:t>
             </a:r>
             <a:r>
-              <a:rPr sz="1000" b="0" i="0">
+              <a:rPr sz="950" b="0" i="0">
                 <a:solidFill>
                   <a:srgbClr val="595959"/>
                 </a:solidFill>
                 <a:latin typeface="Arial"/>
               </a:rPr>
-              <a:t>44 tests, clean under Address-, UB- and ThreadSanitizer; history on topic branches.</a:t>
+              <a:t>44 tests, clean under Address-, UB- and ThreadSanitizer; history on feature branches.</a:t>
             </a:r>
           </a:p>
         </p:txBody>
@@ -13391,7 +13424,7 @@
                 <a:spcPct val="108000"/>
               </a:lnSpc>
               <a:spcAft>
-                <a:spcPts val="900"/>
+                <a:spcPts val="800"/>
               </a:spcAft>
               <a:buClr>
                 <a:srgbClr val="4285F4"/>
@@ -13400,7 +13433,7 @@
               <a:buChar char="•"/>
             </a:pPr>
             <a:r>
-              <a:rPr sz="1100" b="1" i="0">
+              <a:rPr sz="1050" b="1" i="0">
                 <a:solidFill>
                   <a:srgbClr val="212121"/>
                 </a:solidFill>
@@ -13409,7 +13442,7 @@
               <a:t>The window chain is a prefix computation, </a:t>
             </a:r>
             <a:r>
-              <a:rPr sz="1100" b="0" i="0">
+              <a:rPr sz="1050" b="0" i="0">
                 <a:solidFill>
                   <a:srgbClr val="595959"/>
                 </a:solidFill>
@@ -13424,7 +13457,7 @@
                 <a:spcPct val="108000"/>
               </a:lnSpc>
               <a:spcAft>
-                <a:spcPts val="900"/>
+                <a:spcPts val="800"/>
               </a:spcAft>
               <a:buClr>
                 <a:srgbClr val="4285F4"/>
@@ -13433,7 +13466,7 @@
               <a:buChar char="•"/>
             </a:pPr>
             <a:r>
-              <a:rPr sz="1100" b="1" i="0">
+              <a:rPr sz="1050" b="1" i="0">
                 <a:solidFill>
                   <a:srgbClr val="212121"/>
                 </a:solidFill>
@@ -13442,7 +13475,7 @@
               <a:t>Measured: </a:t>
             </a:r>
             <a:r>
-              <a:rPr sz="1100" b="0" i="0">
+              <a:rPr sz="1050" b="0" i="0">
                 <a:solidFill>
                   <a:srgbClr val="595959"/>
                 </a:solidFill>
@@ -13457,7 +13490,7 @@
                 <a:spcPct val="108000"/>
               </a:lnSpc>
               <a:spcAft>
-                <a:spcPts val="900"/>
+                <a:spcPts val="800"/>
               </a:spcAft>
               <a:buClr>
                 <a:srgbClr val="4285F4"/>
@@ -13466,7 +13499,7 @@
               <a:buChar char="•"/>
             </a:pPr>
             <a:r>
-              <a:rPr sz="1100" b="1" i="0">
+              <a:rPr sz="1050" b="1" i="0">
                 <a:solidFill>
                   <a:srgbClr val="212121"/>
                 </a:solidFill>
@@ -13475,7 +13508,7 @@
               <a:t>Splitting oversized chunks </a:t>
             </a:r>
             <a:r>
-              <a:rPr sz="1100" b="0" i="0">
+              <a:rPr sz="1050" b="0" i="0">
                 <a:solidFill>
                   <a:srgbClr val="595959"/>
                 </a:solidFill>
@@ -13490,7 +13523,7 @@
                 <a:spcPct val="108000"/>
               </a:lnSpc>
               <a:spcAft>
-                <a:spcPts val="900"/>
+                <a:spcPts val="800"/>
               </a:spcAft>
               <a:buClr>
                 <a:srgbClr val="4285F4"/>
@@ -13499,7 +13532,40 @@
               <a:buChar char="•"/>
             </a:pPr>
             <a:r>
-              <a:rPr sz="1100" b="1" i="0">
+              <a:rPr sz="1050" b="1" i="0">
+                <a:solidFill>
+                  <a:srgbClr val="212121"/>
+                </a:solidFill>
+                <a:latin typeface="Arial"/>
+              </a:rPr>
+              <a:t>Against rapidgzip: </a:t>
+            </a:r>
+            <a:r>
+              <a:rPr sz="1050" b="0" i="0">
+                <a:solidFill>
+                  <a:srgbClr val="595959"/>
+                </a:solidFill>
+                <a:latin typeface="Arial"/>
+              </a:rPr>
+              <a:t>level at 10 threads, faster with few threads; it still wins on memory and small chunks.</a:t>
+            </a:r>
+          </a:p>
+          <a:p>
+            <a:pPr marL="164592" indent="-164592">
+              <a:lnSpc>
+                <a:spcPct val="108000"/>
+              </a:lnSpc>
+              <a:spcAft>
+                <a:spcPts val="800"/>
+              </a:spcAft>
+              <a:buClr>
+                <a:srgbClr val="4285F4"/>
+              </a:buClr>
+              <a:buFont typeface="Arial"/>
+              <a:buChar char="•"/>
+            </a:pPr>
+            <a:r>
+              <a:rPr sz="1050" b="1" i="0">
                 <a:solidFill>
                   <a:srgbClr val="212121"/>
                 </a:solidFill>
@@ -13508,13 +13574,13 @@
               <a:t>Future scope: </a:t>
             </a:r>
             <a:r>
-              <a:rPr sz="1100" b="0" i="0">
+              <a:rPr sz="1050" b="0" i="0">
                 <a:solidFill>
                   <a:srgbClr val="595959"/>
                 </a:solidFill>
                 <a:latin typeface="Arial"/>
               </a:rPr>
-              <a:t>port M3 into rapidgzip for 64–128 cores; compact marker spans (M2); streaming output; GPU window composition.</a:t>
+              <a:t>streaming output and lower per-chunk cost; M3 inside rapidgzip on 64–128 cores; compact marker spans (M2); GPU window composition.</a:t>
             </a:r>
           </a:p>
         </p:txBody>
@@ -13777,7 +13843,7 @@
                 </a:solidFill>
                 <a:latin typeface="Arial"/>
               </a:rPr>
-              <a:t>Done   Evaluation: 1 200 runs</a:t>
+              <a:t>Done   Evaluation + rapidgzip comparison</a:t>
             </a:r>
           </a:p>
         </p:txBody>
@@ -13832,7 +13898,7 @@
                 </a:solidFill>
                 <a:latin typeface="Arial"/>
               </a:rPr>
-              <a:t>Next   M3 inside rapidgzip, 128 cores</a:t>
+              <a:t>Next   Streaming output; M3 inside rapidgzip</a:t>
             </a:r>
           </a:p>
         </p:txBody>
@@ -14104,7 +14170,7 @@
                 </a:solidFill>
                 <a:latin typeface="Arial"/>
               </a:rPr>
-              <a:t>Honest limit: </a:t>
+              <a:t>Limits: </a:t>
             </a:r>
             <a:r>
               <a:rPr sz="950" b="0" i="0">
@@ -14113,7 +14179,7 @@
                 </a:solidFill>
                 <a:latin typeface="Arial"/>
               </a:rPr>
-              <a:t>from 1 MiB up the chain is under 2% of the run; no measurable change.</a:t>
+              <a:t>from 1 MiB up the chain is under 2% of the run; at 64 KiB rapidgzip is still 1.3× faster than us (our other per-chunk costs are higher).</a:t>
             </a:r>
           </a:p>
         </p:txBody>

</xml_diff>

<commit_message>
Rewrite the final presentation text in plainer language
Shorter, plainer bullets and speaker notes in the words we use when
presenting; numbers are unchanged.
</commit_message>
<xml_diff>
--- a/docs/final/riptide_final_presentation.pptx
+++ b/docs/final/riptide_final_presentation.pptx
@@ -287,7 +287,7 @@
                 </a:solidFill>
                 <a:latin typeface="Arial"/>
               </a:rPr>
-              <a:t>Throughput (GB/s) against threads, 4 MiB chunks</a:t>
+              <a:t>Throughput (GB/s) vs threads, 4 MiB chunks</a:t>
             </a:r>
           </a:p>
         </c:rich>
@@ -309,7 +309,7 @@
               <c:strCache>
                 <c:ptCount val="1"/>
                 <c:pt idx="0">
-                  <c:v>Silesia ×5</c:v>
+                  <c:v>Silesia x5</c:v>
                 </c:pt>
               </c:strCache>
             </c:strRef>
@@ -932,7 +932,7 @@
                 </a:solidFill>
                 <a:latin typeface="Arial"/>
               </a:rPr>
-              <a:t>Window resolution time (ms), Silesia ×5, 10 threads</a:t>
+              <a:t>Time to resolve windows (ms), Silesia x5, 10 threads</a:t>
             </a:r>
           </a:p>
         </c:rich>
@@ -954,7 +954,7 @@
               <c:strCache>
                 <c:ptCount val="1"/>
                 <c:pt idx="0">
-                  <c:v>Serial chain (base paper)</c:v>
+                  <c:v>One by one (rapidgzip)</c:v>
                 </c:pt>
               </c:strCache>
             </c:strRef>
@@ -1026,7 +1026,7 @@
               <c:strCache>
                 <c:ptCount val="1"/>
                 <c:pt idx="0">
-                  <c:v>Blocked prefix scan (ours)</c:v>
+                  <c:v>Blocked scan (ours)</c:v>
                 </c:pt>
               </c:strCache>
             </c:strRef>
@@ -1869,7 +1869,7 @@
           <a:lstStyle/>
           <a:p>
             <a:r>
-              <a:t>Riptide decompresses ordinary gzip files on all cores and gives output identical to zlib. We built the whole decoder from scratch and parallelised the one step our base paper left serial.</a:t>
+              <a:t>Our project is Riptide. It decompresses normal .gz files using all the cores, and the output is exactly what zlib gives. We wrote the decoder ourselves and worked on the one step our base paper keeps serial.</a:t>
             </a:r>
           </a:p>
         </p:txBody>
@@ -1958,7 +1958,7 @@
           <a:lstStyle/>
           <a:p>
             <a:r>
-              <a:t>Two dependencies make gzip serial: no index of block starts, and copies from up to 32 KiB back. rapidgzip solves both with speculative decoding and markers, but resolves the windows between chunks one after another. That is the step we parallelise.</a:t>
+              <a:t>Even today, gunzip on a big file uses one core. There are two reasons: you can't tell where a block starts without decoding everything before it, and a match can copy from up to 32 KB back. rapidgzip gets around both, but it still passes the windows from chunk to chunk one at a time. That's the part we looked at.</a:t>
             </a:r>
           </a:p>
         </p:txBody>
@@ -2061,7 +2061,7 @@
           <a:lstStyle/>
           <a:p>
             <a:r>
-              <a:t>Amber stages contain our contributions. Each chunk's final window is a map from the window before it; maps compose associatively, so the chain is a prefix scan. A chunk that exceeds its output budget is split and handed to idle workers instead of finishing on one thread. Everything, including the decoder itself, is our own code.</a:t>
+              <a:t>The orange boxes are our parts. Each chunk's last 32 KB depends on the chunk before it, but if you treat that dependency as a function, two of them combine into one function of the same kind, and the combining is associative. That's all you need for a prefix scan. The other change is for chunks that grow past their memory budget: we split them up instead of letting one thread finish them.</a:t>
             </a:r>
           </a:p>
         </p:txBody>
@@ -2164,7 +2164,7 @@
           <a:lstStyle/>
           <a:p>
             <a:r>
-              <a:t>Correctness first: every one of 1,200 timed runs matched zlib byte for byte. Silesia times five reaches 3 GB/s with 10 threads, two and a half times zlib. Efficiency is about 0.3 because six of the ten cores are efficiency cores and two-stage decoding has to replace markers afterwards. On the highly compressible logs zlib still wins, and we say so.</a:t>
+              <a:t>First, correctness: all 1,200 timed runs gave exactly the same bytes as zlib. On the biggest Silesia file we get about 3 GB/s with 10 threads, roughly two and a half times zlib. Efficiency isn't great, around 0.3, partly because six of the ten cores on this laptop are the small ones. And on the very compressible logs file zlib is still faster than us.</a:t>
             </a:r>
           </a:p>
         </p:txBody>
@@ -2253,7 +2253,7 @@
           <a:lstStyle/>
           <a:p>
             <a:r>
-              <a:t>Everything on the slide is our own code and our own measurements. The bugs we list are the ones that cost us most time: the race only showed up in one run in eight, and the memory problem only appeared on gigabyte-sized inputs. We also ran rapidgzip, the base paper's own tool, on the same laptop: at 10 threads the two are statistically level.</a:t>
+              <a:t>Everything here is our own code. The bugs on the left are the ones that cost us the most time. The race only failed about once in eight runs, so it took a while to even reproduce, and the memory problem only showed up once we tried 1 GB files. We also downloaded rapidgzip and ran it on the same laptop to compare.</a:t>
             </a:r>
           </a:p>
         </p:txBody>
@@ -2342,7 +2342,7 @@
           <a:lstStyle/>
           <a:p>
             <a:r>
-              <a:t>Our claim is narrow and measured: the base paper's serial step parallelises, and it pays off exactly when chunks are small. Against the base paper's own tool we are level at 10 threads, and we name where it is still better: memory and small chunks. The next steps are streaming output, which closes the memory gap, and putting the scan into rapidgzip on the core counts where it stops scaling.</a:t>
+              <a:t>To sum up: the step rapidgzip calls serial can be done with a prefix scan, and it pays off with small chunks. We're level with rapidgzip at 10 threads, and it's still better on memory and on small chunks. Next we'd stream the output, which should fix most of the memory gap, and then try the scan inside rapidgzip on a big server.</a:t>
             </a:r>
           </a:p>
         </p:txBody>
@@ -2400,7 +2400,7 @@
           <a:lstStyle/>
           <a:p>
             <a:r>
-              <a:t>This is the main result. The blocked scan resolves the windows three to four times faster than the serial chain at every chunk size, and it keeps getting faster with more cores while the chain does not. It matters for the whole run when chunks are small, which is also when memory use is lowest. Two limits we state ourselves: with large chunks the chain was already cheap, and with 64 KiB chunks rapidgzip is still faster than our whole decoder, because our block search and per-chunk bookkeeping cost more than theirs. So M3 is proven inside Riptide; inside rapidgzip it is future work.</a:t>
+              <a:t>This is M3. The blue bars are our scan, the orange ones are the chain done one by one, which is how rapidgzip does it. The scan is three to four times faster and keeps improving with more threads. It only shows up in the total time when chunks are small, though. With big chunks the chain was already cheap. Also, rapidgzip handles 64 KB chunks better than our decoder overall, because our block search and per-chunk bookkeeping cost more. So we can say M3 works in Riptide; whether it helps inside rapidgzip we haven't tested.</a:t>
             </a:r>
           </a:p>
         </p:txBody>
@@ -2458,7 +2458,7 @@
           <a:lstStyle/>
           <a:p>
             <a:r>
-              <a:t>When an output budget turns a few large chunks into chains of continuations, splitting them brings load imbalance from 5.6 to 1.3 and makes the run 1.6 times faster. With many small chunks it makes no difference, and our header-based chunk planner did not pay off, which we report as a negative result. Against rapidgzip itself, run on the same laptop, we are level at 10 threads and faster with few threads, but rapidgzip uses much less memory because it streams its output, and it is faster with small chunks, so we do not claim M3 would speed rapidgzip up without porting it.</a:t>
+              <a:t>Left side is M1. When a chunk grows past its memory budget, rapidgzip's approach leaves the rest to one thread. We split it across idle threads, and with few large chunks that took the imbalance from 5.6 down to 1.3. With lots of small chunks it doesn't matter. Our other idea, sizing chunks from the Huffman headers, didn't pay off, so we're reporting that as a negative result. On the right we ran rapidgzip itself on the same laptop. At 10 threads we're about the same speed. It uses a lot less memory than we do, because it streams the output and we keep all of it.</a:t>
             </a:r>
           </a:p>
         </p:txBody>
@@ -10744,22 +10744,13 @@
               <a:buChar char="•"/>
             </a:pPr>
             <a:r>
-              <a:rPr sz="1050" b="1" i="0">
-                <a:solidFill>
-                  <a:srgbClr val="212121"/>
+              <a:rPr sz="1050" b="0" i="0">
+                <a:solidFill>
+                  <a:srgbClr val="595959"/>
                 </a:solidFill>
                 <a:latin typeface="Arial"/>
               </a:rPr>
-              <a:t>One core per file. </a:t>
-            </a:r>
-            <a:r>
-              <a:rPr sz="1050" b="0" i="0">
-                <a:solidFill>
-                  <a:srgbClr val="595959"/>
-                </a:solidFill>
-                <a:latin typeface="Arial"/>
-              </a:rPr>
-              <a:t>zlib and pigz decode a .gz on one core, however many the machine has.</a:t>
+              <a:t>Unzipping a large .gz file still uses one CPU core, even on a machine with 10 or 64 cores.</a:t>
             </a:r>
           </a:p>
           <a:p>
@@ -10777,22 +10768,13 @@
               <a:buChar char="•"/>
             </a:pPr>
             <a:r>
-              <a:rPr sz="1050" b="1" i="0">
-                <a:solidFill>
-                  <a:srgbClr val="212121"/>
+              <a:rPr sz="1050" b="0" i="0">
+                <a:solidFill>
+                  <a:srgbClr val="595959"/>
                 </a:solidFill>
                 <a:latin typeface="Arial"/>
               </a:rPr>
-              <a:t>Why: </a:t>
-            </a:r>
-            <a:r>
-              <a:rPr sz="1050" b="0" i="0">
-                <a:solidFill>
-                  <a:srgbClr val="595959"/>
-                </a:solidFill>
-                <a:latin typeface="Arial"/>
-              </a:rPr>
-              <a:t>blocks have no index and are not byte-aligned, and back-references copy up to 32 KiB of earlier output.</a:t>
+              <a:t>The reason: DEFLATE blocks have no index and aren't byte-aligned, and a match can copy data from up to 32 KB earlier in the output.</a:t>
             </a:r>
           </a:p>
           <a:p>
@@ -10816,7 +10798,7 @@
                 </a:solidFill>
                 <a:latin typeface="Arial"/>
               </a:rPr>
-              <a:t>The state of the art leaves a serial step. </a:t>
+              <a:t>rapidgzip (HPDC '23)</a:t>
             </a:r>
             <a:r>
               <a:rPr sz="1050" b="0" i="0">
@@ -10825,7 +10807,7 @@
                 </a:solidFill>
                 <a:latin typeface="Arial"/>
               </a:rPr>
-              <a:t>rapidgzip (HPDC '23) decodes chunks in parallel but resolves the windows between them one by one, and states this cannot be parallelised.</a:t>
+              <a:t> already decodes chunks in parallel, but it fixes up the 32 KB windows one chunk at a time, and the paper says that part can't be parallelised.</a:t>
             </a:r>
           </a:p>
           <a:p>
@@ -10843,22 +10825,13 @@
               <a:buChar char="•"/>
             </a:pPr>
             <a:r>
-              <a:rPr sz="1050" b="1" i="0">
-                <a:solidFill>
-                  <a:srgbClr val="212121"/>
+              <a:rPr sz="1050" b="0" i="0">
+                <a:solidFill>
+                  <a:srgbClr val="595959"/>
                 </a:solidFill>
                 <a:latin typeface="Arial"/>
               </a:rPr>
-              <a:t>Our aim: </a:t>
-            </a:r>
-            <a:r>
-              <a:rPr sz="1050" b="0" i="0">
-                <a:solidFill>
-                  <a:srgbClr val="595959"/>
-                </a:solidFill>
-                <a:latin typeface="Arial"/>
-              </a:rPr>
-              <a:t>parallelise that step and the handling of oversized chunks, output byte-identical to zlib.</a:t>
+              <a:t>We wanted to check whether that step really has to be serial, and also handle chunks that expand too much.</a:t>
             </a:r>
           </a:p>
         </p:txBody>
@@ -10893,7 +10866,7 @@
                 </a:solidFill>
                 <a:latin typeface="Arial"/>
               </a:rPr>
-              <a:t>Stakeholders and how they benefit</a:t>
+              <a:t>Who benefits</a:t>
             </a:r>
           </a:p>
         </p:txBody>
@@ -10932,7 +10905,7 @@
                           </a:solidFill>
                           <a:latin typeface="Arial"/>
                         </a:rPr>
-                        <a:t>Stakeholder</a:t>
+                        <a:t>Who</a:t>
                       </a:r>
                     </a:p>
                   </a:txBody>
@@ -10955,7 +10928,7 @@
                           </a:solidFill>
                           <a:latin typeface="Arial"/>
                         </a:rPr>
-                        <a:t>Benefit</a:t>
+                        <a:t>How</a:t>
                       </a:r>
                     </a:p>
                   </a:txBody>
@@ -10980,7 +10953,7 @@
                           </a:solidFill>
                           <a:latin typeface="Arial"/>
                         </a:rPr>
-                        <a:t>Bioinformatics labs</a:t>
+                        <a:t>Genomics labs</a:t>
                       </a:r>
                     </a:p>
                   </a:txBody>
@@ -11003,7 +10976,7 @@
                           </a:solidFill>
                           <a:latin typeface="Arial"/>
                         </a:rPr>
-                        <a:t>Archived .fastq.gz re-analysed without a one-thread bottleneck</a:t>
+                        <a:t>Old .fastq.gz files decompress faster when they are re-analysed</a:t>
                       </a:r>
                     </a:p>
                   </a:txBody>
@@ -11051,7 +11024,7 @@
                           </a:solidFill>
                           <a:latin typeface="Arial"/>
                         </a:rPr>
-                        <a:t>Gzipped logs, CSV and JSON read at multi-core speed, no re-encoding</a:t>
+                        <a:t>Gzipped logs, CSV and JSON load faster, no re-compressing</a:t>
                       </a:r>
                     </a:p>
                   </a:txBody>
@@ -11076,7 +11049,7 @@
                           </a:solidFill>
                           <a:latin typeface="Arial"/>
                         </a:rPr>
-                        <a:t>DevOps / CI teams</a:t>
+                        <a:t>DevOps / CI</a:t>
                       </a:r>
                     </a:p>
                   </a:txBody>
@@ -11099,7 +11072,7 @@
                           </a:solidFill>
                           <a:latin typeface="Arial"/>
                         </a:rPr>
-                        <a:t>Faster extraction of release tarballs and container layers</a:t>
+                        <a:t>Faster extraction of tarballs and container layers</a:t>
                       </a:r>
                     </a:p>
                   </a:txBody>
@@ -11124,7 +11097,7 @@
                           </a:solidFill>
                           <a:latin typeface="Arial"/>
                         </a:rPr>
-                        <a:t>Archive hosts</a:t>
+                        <a:t>Archives</a:t>
                       </a:r>
                     </a:p>
                   </a:txBody>
@@ -11147,7 +11120,7 @@
                           </a:solidFill>
                           <a:latin typeface="Arial"/>
                         </a:rPr>
-                        <a:t>Existing .gz data stays as it is; no migration</a:t>
+                        <a:t>Existing .gz files can stay as they are</a:t>
                       </a:r>
                     </a:p>
                   </a:txBody>
@@ -11425,7 +11398,7 @@
                 </a:solidFill>
                 <a:latin typeface="Arial"/>
               </a:rPr>
-              <a:t>2. Speculative decode</a:t>
+              <a:t>2. Decode chunks</a:t>
             </a:r>
           </a:p>
           <a:p>
@@ -11449,7 +11422,7 @@
                 </a:solidFill>
                 <a:latin typeface="Arial"/>
               </a:rPr>
-              <a:t>M1 · split on overflow</a:t>
+              <a:t>M1: split big chunks</a:t>
             </a:r>
           </a:p>
         </p:txBody>
@@ -11506,7 +11479,7 @@
                 </a:solidFill>
                 <a:latin typeface="Arial"/>
               </a:rPr>
-              <a:t>3. Chain linking</a:t>
+              <a:t>3. Link chunks</a:t>
             </a:r>
           </a:p>
           <a:p>
@@ -11518,7 +11491,7 @@
                 </a:solidFill>
                 <a:latin typeface="Arial"/>
               </a:rPr>
-              <a:t>(follow block ends)</a:t>
+              <a:t>in order</a:t>
             </a:r>
           </a:p>
         </p:txBody>
@@ -11575,7 +11548,7 @@
                 </a:solidFill>
                 <a:latin typeface="Arial"/>
               </a:rPr>
-              <a:t>4. Window resolution</a:t>
+              <a:t>4. Resolve windows</a:t>
             </a:r>
           </a:p>
           <a:p>
@@ -11587,7 +11560,7 @@
                 </a:solidFill>
                 <a:latin typeface="Arial"/>
               </a:rPr>
-              <a:t>by prefix scan</a:t>
+              <a:t>(prefix scan)</a:t>
             </a:r>
           </a:p>
           <a:p>
@@ -11599,7 +11572,7 @@
                 </a:solidFill>
                 <a:latin typeface="Arial"/>
               </a:rPr>
-              <a:t>M3 · primary</a:t>
+              <a:t>M3 (main idea)</a:t>
             </a:r>
           </a:p>
         </p:txBody>
@@ -11656,7 +11629,7 @@
                 </a:solidFill>
                 <a:latin typeface="Arial"/>
               </a:rPr>
-              <a:t>5. Marker replace-</a:t>
+              <a:t>5. Fill in markers,</a:t>
             </a:r>
           </a:p>
           <a:p>
@@ -11668,7 +11641,7 @@
                 </a:solidFill>
                 <a:latin typeface="Arial"/>
               </a:rPr>
-              <a:t>ment, assembly</a:t>
+              <a:t>join chunks</a:t>
             </a:r>
           </a:p>
         </p:txBody>
@@ -11725,7 +11698,7 @@
                 </a:solidFill>
                 <a:latin typeface="Arial"/>
               </a:rPr>
-              <a:t>6. CRC-32 per block,</a:t>
+              <a:t>6. Check CRC-32</a:t>
             </a:r>
           </a:p>
           <a:p>
@@ -11737,7 +11710,7 @@
                 </a:solidFill>
                 <a:latin typeface="Arial"/>
               </a:rPr>
-              <a:t>combined</a:t>
+              <a:t>(in parallel)</a:t>
             </a:r>
           </a:p>
         </p:txBody>
@@ -11794,7 +11767,7 @@
                 </a:solidFill>
                 <a:latin typeface="Arial"/>
               </a:rPr>
-              <a:t>Output identical</a:t>
+              <a:t>Output (same</a:t>
             </a:r>
           </a:p>
           <a:p>
@@ -11806,7 +11779,7 @@
                 </a:solidFill>
                 <a:latin typeface="Arial"/>
               </a:rPr>
-              <a:t>to zlib</a:t>
+              <a:t>as zlib)</a:t>
             </a:r>
           </a:p>
         </p:txBody>
@@ -11863,7 +11836,7 @@
                 </a:solidFill>
                 <a:latin typeface="Arial"/>
               </a:rPr>
-              <a:t>Work-stealing thread pool</a:t>
+              <a:t>Thread pool (work stealing)</a:t>
             </a:r>
           </a:p>
           <a:p>
@@ -11875,7 +11848,7 @@
                 </a:solidFill>
                 <a:latin typeface="Arial"/>
               </a:rPr>
-              <a:t>runs every stage except 3</a:t>
+              <a:t>used by every step except 3</a:t>
             </a:r>
           </a:p>
         </p:txBody>
@@ -12162,7 +12135,7 @@
                 </a:solidFill>
                 <a:latin typeface="Arial"/>
               </a:rPr>
-              <a:t>How this differs from the base paper: rapidgzip (Knespel &amp; Brunst, HPDC '23)</a:t>
+              <a:t>What's different from rapidgzip (Knespel &amp; Brunst, HPDC '23)</a:t>
             </a:r>
           </a:p>
         </p:txBody>
@@ -12217,7 +12190,7 @@
                 </a:solidFill>
                 <a:latin typeface="Arial"/>
               </a:rPr>
-              <a:t>M3 · Window resolution (primary)</a:t>
+              <a:t>M3: the window step</a:t>
             </a:r>
           </a:p>
           <a:p>
@@ -12229,7 +12202,7 @@
                 </a:solidFill>
                 <a:latin typeface="Arial"/>
               </a:rPr>
-              <a:t>Base paper: windows resolved one chunk after another; stated to be unparallelisable.</a:t>
+              <a:t>rapidgzip passes the 32 KB windows along one chunk at a time and says this can't be parallelised.</a:t>
             </a:r>
           </a:p>
           <a:p>
@@ -12241,7 +12214,7 @@
                 </a:solidFill>
                 <a:latin typeface="Arial"/>
               </a:rPr>
-              <a:t>Ours: maps compose associatively → blocked prefix scan, 2.9–3.9× faster.</a:t>
+              <a:t>We combine windows like functions, so a parallel prefix scan works. 2.9-3.9x faster.</a:t>
             </a:r>
           </a:p>
         </p:txBody>
@@ -12296,7 +12269,7 @@
                 </a:solidFill>
                 <a:latin typeface="Arial"/>
               </a:rPr>
-              <a:t>M1 · Oversized chunks</a:t>
+              <a:t>M1: chunks that expand a lot</a:t>
             </a:r>
           </a:p>
           <a:p>
@@ -12308,7 +12281,7 @@
                 </a:solidFill>
                 <a:latin typeface="Arial"/>
               </a:rPr>
-              <a:t>Base paper's software: the rest of a chunk past its output budget is decoded on one thread.</a:t>
+              <a:t>In rapidgzip the rest of an oversized chunk is decoded by a single thread.</a:t>
             </a:r>
           </a:p>
           <a:p>
@@ -12320,7 +12293,7 @@
                 </a:solidFill>
                 <a:latin typeface="Arial"/>
               </a:rPr>
-              <a:t>Ours: split across idle workers; λ 5.6 → 1.3 when chunks are few.</a:t>
+              <a:t>We split the rest across free threads. Imbalance went from 5.6 to 1.3.</a:t>
             </a:r>
           </a:p>
         </p:txBody>
@@ -12375,7 +12348,7 @@
                 </a:solidFill>
                 <a:latin typeface="Arial"/>
               </a:rPr>
-              <a:t>Built from scratch</a:t>
+              <a:t>Written from scratch</a:t>
             </a:r>
           </a:p>
           <a:p>
@@ -12387,7 +12360,7 @@
                 </a:solidFill>
                 <a:latin typeface="Arial"/>
               </a:rPr>
-              <a:t>Inflate, block finder, work-stealing pool, 3 parallel scans, parallel CRC-32: ~5 300 lines of C++20.</a:t>
+              <a:t>Decoder, block finder, thread pool, 3 scans and CRC-32. About 5,300 lines of C++.</a:t>
             </a:r>
           </a:p>
           <a:p>
@@ -12399,7 +12372,7 @@
                 </a:solidFill>
                 <a:latin typeface="Arial"/>
               </a:rPr>
-              <a:t>44 tests, sanitizer-clean, byte-identical to zlib in 1 200 of 1 200 runs.</a:t>
+              <a:t>44 tests. Output matched zlib in all 1,200 runs.</a:t>
             </a:r>
           </a:p>
         </p:txBody>
@@ -12525,7 +12498,7 @@
                 </a:solidFill>
                 <a:latin typeface="Arial"/>
               </a:rPr>
-              <a:t>Apple M4: 4 performance + 6 efficiency cores. Medians of 10 runs, interleaved across configurations. Logs: zlib reaches 6.04 GB/s (off the chart).</a:t>
+              <a:t>Apple M4 laptop (4 fast + 6 slower cores). Median of 10 runs. zlib on the logs file reaches 6.04 GB/s, which is off the chart.</a:t>
             </a:r>
           </a:p>
         </p:txBody>
@@ -12592,7 +12565,7 @@
                 </a:solidFill>
                 <a:latin typeface="Arial"/>
               </a:rPr>
-              <a:t>timed runs byte-identical to zlib</a:t>
+              <a:t>runs matched zlib byte for byte</a:t>
             </a:r>
           </a:p>
         </p:txBody>
@@ -12659,7 +12632,7 @@
                 </a:solidFill>
                 <a:latin typeface="Arial"/>
               </a:rPr>
-              <a:t>Silesia ×5, 10 threads: 2.5× zlib, 4.4× our sequential decoder</a:t>
+              <a:t>Silesia x5 with 10 threads (2.5x zlib)</a:t>
             </a:r>
           </a:p>
         </p:txBody>
@@ -12714,7 +12687,7 @@
                 </a:solidFill>
                 <a:latin typeface="Arial"/>
               </a:rPr>
-              <a:t>2.1×</a:t>
+              <a:t>2.1x</a:t>
             </a:r>
           </a:p>
           <a:p>
@@ -12726,7 +12699,7 @@
                 </a:solidFill>
                 <a:latin typeface="Arial"/>
               </a:rPr>
-              <a:t>faster than zlib on the Silesia corpus (the base paper's benchmark)</a:t>
+              <a:t>faster than zlib on Silesia, the base paper's benchmark</a:t>
             </a:r>
           </a:p>
         </p:txBody>
@@ -12767,22 +12740,13 @@
               <a:buChar char="•"/>
             </a:pPr>
             <a:r>
-              <a:rPr sz="900" b="1" i="0">
-                <a:solidFill>
-                  <a:srgbClr val="212121"/>
+              <a:rPr sz="900" b="0" i="0">
+                <a:solidFill>
+                  <a:srgbClr val="595959"/>
                 </a:solidFill>
                 <a:latin typeface="Arial"/>
               </a:rPr>
-              <a:t>Efficiency ≈ 0.3 at 10 threads: </a:t>
-            </a:r>
-            <a:r>
-              <a:rPr sz="900" b="0" i="0">
-                <a:solidFill>
-                  <a:srgbClr val="595959"/>
-                </a:solidFill>
-                <a:latin typeface="Arial"/>
-              </a:rPr>
-              <a:t>efficiency cores are slower, and marker replacement adds work.</a:t>
+              <a:t>Efficiency is only about 0.3 at 10 threads. Six of the cores are the slower efficiency cores, and filling in markers is an extra pass.</a:t>
             </a:r>
           </a:p>
           <a:p>
@@ -12800,22 +12764,13 @@
               <a:buChar char="•"/>
             </a:pPr>
             <a:r>
-              <a:rPr sz="900" b="1" i="0">
-                <a:solidFill>
-                  <a:srgbClr val="212121"/>
+              <a:rPr sz="900" b="0" i="0">
+                <a:solidFill>
+                  <a:srgbClr val="595959"/>
                 </a:solidFill>
                 <a:latin typeface="Arial"/>
               </a:rPr>
-              <a:t>Logs (23×): </a:t>
-            </a:r>
-            <a:r>
-              <a:rPr sz="900" b="0" i="0">
-                <a:solidFill>
-                  <a:srgbClr val="595959"/>
-                </a:solidFill>
-                <a:latin typeface="Arial"/>
-              </a:rPr>
-              <a:t>94% of output is markers; zlib, doing long copies, stays faster.</a:t>
+              <a:t>On the logs file zlib is faster: 94% of that output is markers.</a:t>
             </a:r>
           </a:p>
         </p:txBody>
@@ -12915,7 +12870,7 @@
                 </a:solidFill>
                 <a:latin typeface="Arial"/>
               </a:rPr>
-              <a:t>Built and measured</a:t>
+              <a:t>What we built</a:t>
             </a:r>
           </a:p>
         </p:txBody>
@@ -12956,22 +12911,13 @@
               <a:buChar char="•"/>
             </a:pPr>
             <a:r>
-              <a:rPr sz="950" b="1" i="0">
-                <a:solidFill>
-                  <a:srgbClr val="212121"/>
+              <a:rPr sz="950" b="0" i="0">
+                <a:solidFill>
+                  <a:srgbClr val="595959"/>
                 </a:solidFill>
                 <a:latin typeface="Arial"/>
               </a:rPr>
-              <a:t>A complete parallel gzip decoder from scratch: </a:t>
-            </a:r>
-            <a:r>
-              <a:rPr sz="950" b="0" i="0">
-                <a:solidFill>
-                  <a:srgbClr val="595959"/>
-                </a:solidFill>
-                <a:latin typeface="Arial"/>
-              </a:rPr>
-              <a:t>Huffman tables, inflate, block finder, work-stealing pool, three scans, parallel CRC-32.</a:t>
+              <a:t>A parallel gzip decoder written from scratch in C++: Huffman decoding, inflate, block finder, thread pool, three prefix scans and parallel CRC-32.</a:t>
             </a:r>
           </a:p>
           <a:p>
@@ -12989,22 +12935,13 @@
               <a:buChar char="•"/>
             </a:pPr>
             <a:r>
-              <a:rPr sz="950" b="1" i="0">
-                <a:solidFill>
-                  <a:srgbClr val="212121"/>
+              <a:rPr sz="950" b="0" i="0">
+                <a:solidFill>
+                  <a:srgbClr val="595959"/>
                 </a:solidFill>
                 <a:latin typeface="Arial"/>
               </a:rPr>
-              <a:t>M3 and M1 implemented and evaluated </a:t>
-            </a:r>
-            <a:r>
-              <a:rPr sz="950" b="0" i="0">
-                <a:solidFill>
-                  <a:srgbClr val="595959"/>
-                </a:solidFill>
-                <a:latin typeface="Arial"/>
-              </a:rPr>
-              <a:t>on five datasets, 1 200 timed runs, with significance tests.</a:t>
+              <a:t>M3 and M1 implemented and measured on 5 datasets (1,200 timed runs).</a:t>
             </a:r>
           </a:p>
           <a:p>
@@ -13028,7 +12965,7 @@
                 </a:solidFill>
                 <a:latin typeface="Arial"/>
               </a:rPr>
-              <a:t>Hard problems solved: </a:t>
+              <a:t>Bugs that took the longest: </a:t>
             </a:r>
             <a:r>
               <a:rPr sz="950" b="0" i="0">
@@ -13037,7 +12974,7 @@
                 </a:solidFill>
                 <a:latin typeface="Arial"/>
               </a:rPr>
-              <a:t>a task-group race, a hang on truncated input, a block search crawling through stored data, peak memory 7× → under 3× the output.</a:t>
+              <a:t>a race in our task groups (failed 1 run in 8), an infinite loop on truncated files, a block search that crawled through uncompressed data, and memory use of 7x the output (now under 3x).</a:t>
             </a:r>
           </a:p>
           <a:p>
@@ -13055,22 +12992,13 @@
               <a:buChar char="•"/>
             </a:pPr>
             <a:r>
-              <a:rPr sz="950" b="1" i="0">
-                <a:solidFill>
-                  <a:srgbClr val="212121"/>
+              <a:rPr sz="950" b="0" i="0">
+                <a:solidFill>
+                  <a:srgbClr val="595959"/>
                 </a:solidFill>
                 <a:latin typeface="Arial"/>
               </a:rPr>
-              <a:t>Benchmarked against the base paper's software: </a:t>
-            </a:r>
-            <a:r>
-              <a:rPr sz="950" b="0" i="0">
-                <a:solidFill>
-                  <a:srgbClr val="595959"/>
-                </a:solidFill>
-                <a:latin typeface="Arial"/>
-              </a:rPr>
-              <a:t>level with rapidgzip at 10 threads, 1.2–1.9× faster with 1–2 threads.</a:t>
+              <a:t>Tested against rapidgzip itself: same speed at 10 threads, faster with 1-2 threads.</a:t>
             </a:r>
           </a:p>
           <a:p>
@@ -13088,22 +13016,13 @@
               <a:buChar char="•"/>
             </a:pPr>
             <a:r>
-              <a:rPr sz="950" b="1" i="0">
-                <a:solidFill>
-                  <a:srgbClr val="212121"/>
+              <a:rPr sz="950" b="0" i="0">
+                <a:solidFill>
+                  <a:srgbClr val="595959"/>
                 </a:solidFill>
                 <a:latin typeface="Arial"/>
               </a:rPr>
-              <a:t>Quality: </a:t>
-            </a:r>
-            <a:r>
-              <a:rPr sz="950" b="0" i="0">
-                <a:solidFill>
-                  <a:srgbClr val="595959"/>
-                </a:solidFill>
-                <a:latin typeface="Arial"/>
-              </a:rPr>
-              <a:t>44 tests, clean under Address-, UB- and ThreadSanitizer; history on feature branches.</a:t>
+              <a:t>44 tests, clean under AddressSanitizer, UBSan and ThreadSanitizer.</a:t>
             </a:r>
           </a:p>
         </p:txBody>
@@ -13138,7 +13057,7 @@
                 </a:solidFill>
                 <a:latin typeface="Arial"/>
               </a:rPr>
-              <a:t>Practical use case and deployment</a:t>
+              <a:t>Use case and deployment</a:t>
             </a:r>
           </a:p>
         </p:txBody>
@@ -13179,22 +13098,13 @@
               <a:buChar char="•"/>
             </a:pPr>
             <a:r>
-              <a:rPr sz="1000" b="1" i="0">
-                <a:solidFill>
-                  <a:srgbClr val="212121"/>
+              <a:rPr sz="1000" b="0" i="0">
+                <a:solidFill>
+                  <a:srgbClr val="595959"/>
                 </a:solidFill>
                 <a:latin typeface="Arial"/>
               </a:rPr>
-              <a:t>Deployed as: </a:t>
-            </a:r>
-            <a:r>
-              <a:rPr sz="1000" b="0" i="0">
-                <a:solidFill>
-                  <a:srgbClr val="595959"/>
-                </a:solidFill>
-                <a:latin typeface="Arial"/>
-              </a:rPr>
-              <a:t>the riptide command-line tool and a C++ library, used in place of gzip -d on existing files.</a:t>
+              <a:t>A command-line tool (riptide) and a C++ library. You can use it instead of gzip -d on files you already have.</a:t>
             </a:r>
           </a:p>
           <a:p>
@@ -13212,22 +13122,13 @@
               <a:buChar char="•"/>
             </a:pPr>
             <a:r>
-              <a:rPr sz="1000" b="1" i="0">
-                <a:solidFill>
-                  <a:srgbClr val="212121"/>
+              <a:rPr sz="1000" b="0" i="0">
+                <a:solidFill>
+                  <a:srgbClr val="595959"/>
                 </a:solidFill>
                 <a:latin typeface="Arial"/>
               </a:rPr>
-              <a:t>Use case: </a:t>
-            </a:r>
-            <a:r>
-              <a:rPr sz="1000" b="0" i="0">
-                <a:solidFill>
-                  <a:srgbClr val="595959"/>
-                </a:solidFill>
-                <a:latin typeface="Arial"/>
-              </a:rPr>
-              <a:t>decompressing reads, logs and archives on multi-core machines without re-encoding them.</a:t>
+              <a:t>Useful for large reads, logs and archives on multi-core machines, with no re-compressing.</a:t>
             </a:r>
           </a:p>
           <a:p>
@@ -13245,22 +13146,13 @@
               <a:buChar char="•"/>
             </a:pPr>
             <a:r>
-              <a:rPr sz="1000" b="1" i="0">
-                <a:solidFill>
-                  <a:srgbClr val="212121"/>
+              <a:rPr sz="1000" b="0" i="0">
+                <a:solidFill>
+                  <a:srgbClr val="595959"/>
                 </a:solidFill>
                 <a:latin typeface="Arial"/>
               </a:rPr>
-              <a:t>Reproducible: </a:t>
-            </a:r>
-            <a:r>
-              <a:rPr sz="1000" b="0" i="0">
-                <a:solidFill>
-                  <a:srgbClr val="595959"/>
-                </a:solidFill>
-                <a:latin typeface="Arial"/>
-              </a:rPr>
-              <a:t>scripts rebuild the datasets, run every experiment and compute the statistics.</a:t>
+              <a:t>All results can be reproduced with the scripts in bench/.</a:t>
             </a:r>
           </a:p>
         </p:txBody>
@@ -13315,7 +13207,7 @@
                 </a:solidFill>
                 <a:latin typeface="Arial"/>
               </a:rPr>
-              <a:t>How stakeholders benefit</a:t>
+              <a:t>Who benefits</a:t>
             </a:r>
           </a:p>
           <a:p>
@@ -13327,7 +13219,7 @@
                 </a:solidFill>
                 <a:latin typeface="Arial"/>
               </a:rPr>
-              <a:t>Up to 2.5× faster than zlib on existing gzip data on a 10-core laptop (1.2–2.5× except on very highly compressed logs), output identical to zlib, nothing to migrate.</a:t>
+              <a:t>Up to 2.5x faster than zlib on a 10-core laptop (1.2-2.5x depending on the file; only the very compressible logs are slower). The output is exactly what zlib gives.</a:t>
             </a:r>
           </a:p>
         </p:txBody>
@@ -13433,22 +13325,13 @@
               <a:buChar char="•"/>
             </a:pPr>
             <a:r>
-              <a:rPr sz="1050" b="1" i="0">
-                <a:solidFill>
-                  <a:srgbClr val="212121"/>
+              <a:rPr sz="1050" b="0" i="0">
+                <a:solidFill>
+                  <a:srgbClr val="595959"/>
                 </a:solidFill>
                 <a:latin typeface="Arial"/>
               </a:rPr>
-              <a:t>The window chain is a prefix computation, </a:t>
-            </a:r>
-            <a:r>
-              <a:rPr sz="1050" b="0" i="0">
-                <a:solidFill>
-                  <a:srgbClr val="595959"/>
-                </a:solidFill>
-                <a:latin typeface="Arial"/>
-              </a:rPr>
-              <a:t>not an inherently serial step: window maps compose associatively.</a:t>
+              <a:t>The window chain isn't inherently serial. Windows combine associatively, so a prefix scan works.</a:t>
             </a:r>
           </a:p>
           <a:p>
@@ -13466,22 +13349,13 @@
               <a:buChar char="•"/>
             </a:pPr>
             <a:r>
-              <a:rPr sz="1050" b="1" i="0">
-                <a:solidFill>
-                  <a:srgbClr val="212121"/>
+              <a:rPr sz="1050" b="0" i="0">
+                <a:solidFill>
+                  <a:srgbClr val="595959"/>
                 </a:solidFill>
                 <a:latin typeface="Arial"/>
               </a:rPr>
-              <a:t>Measured: </a:t>
-            </a:r>
-            <a:r>
-              <a:rPr sz="1050" b="0" i="0">
-                <a:solidFill>
-                  <a:srgbClr val="595959"/>
-                </a:solidFill>
-                <a:latin typeface="Arial"/>
-              </a:rPr>
-              <a:t>a blocked scan resolves windows 2.9–3.9× faster; it matters with small, memory-saving chunks.</a:t>
+              <a:t>The scan makes that step 2.9-3.9x faster, which matters when chunks are small.</a:t>
             </a:r>
           </a:p>
           <a:p>
@@ -13499,22 +13373,13 @@
               <a:buChar char="•"/>
             </a:pPr>
             <a:r>
-              <a:rPr sz="1050" b="1" i="0">
-                <a:solidFill>
-                  <a:srgbClr val="212121"/>
+              <a:rPr sz="1050" b="0" i="0">
+                <a:solidFill>
+                  <a:srgbClr val="595959"/>
                 </a:solidFill>
                 <a:latin typeface="Arial"/>
               </a:rPr>
-              <a:t>Splitting oversized chunks </a:t>
-            </a:r>
-            <a:r>
-              <a:rPr sz="1050" b="0" i="0">
-                <a:solidFill>
-                  <a:srgbClr val="595959"/>
-                </a:solidFill>
-                <a:latin typeface="Arial"/>
-              </a:rPr>
-              <a:t>removes the serialisation an output budget causes when chunks are few (1.59×).</a:t>
+              <a:t>Splitting big chunks gives 1.59x when there are only a few chunks per thread.</a:t>
             </a:r>
           </a:p>
           <a:p>
@@ -13532,22 +13397,13 @@
               <a:buChar char="•"/>
             </a:pPr>
             <a:r>
-              <a:rPr sz="1050" b="1" i="0">
-                <a:solidFill>
-                  <a:srgbClr val="212121"/>
+              <a:rPr sz="1050" b="0" i="0">
+                <a:solidFill>
+                  <a:srgbClr val="595959"/>
                 </a:solidFill>
                 <a:latin typeface="Arial"/>
               </a:rPr>
-              <a:t>Against rapidgzip: </a:t>
-            </a:r>
-            <a:r>
-              <a:rPr sz="1050" b="0" i="0">
-                <a:solidFill>
-                  <a:srgbClr val="595959"/>
-                </a:solidFill>
-                <a:latin typeface="Arial"/>
-              </a:rPr>
-              <a:t>level at 10 threads, faster with few threads; it still wins on memory and small chunks.</a:t>
+              <a:t>Compared with rapidgzip we're level at 10 threads, but it still uses less memory and handles small chunks better.</a:t>
             </a:r>
           </a:p>
           <a:p>
@@ -13571,7 +13427,7 @@
                 </a:solidFill>
                 <a:latin typeface="Arial"/>
               </a:rPr>
-              <a:t>Future scope: </a:t>
+              <a:t>Next: </a:t>
             </a:r>
             <a:r>
               <a:rPr sz="1050" b="0" i="0">
@@ -13580,7 +13436,7 @@
                 </a:solidFill>
                 <a:latin typeface="Arial"/>
               </a:rPr>
-              <a:t>streaming output and lower per-chunk cost; M3 inside rapidgzip on 64–128 cores; compact marker spans (M2); GPU window composition.</a:t>
+              <a:t>stream the output to cut memory, lower our per-chunk overhead, try M3 inside rapidgzip on 64-128 cores, and maybe marker spans (M2) or a GPU version.</a:t>
             </a:r>
           </a:p>
         </p:txBody>
@@ -13615,7 +13471,7 @@
                 </a:solidFill>
                 <a:latin typeface="Arial"/>
               </a:rPr>
-              <a:t>Project status</a:t>
+              <a:t>Status</a:t>
             </a:r>
           </a:p>
         </p:txBody>
@@ -13672,7 +13528,7 @@
                 </a:solidFill>
                 <a:latin typeface="Arial"/>
               </a:rPr>
-              <a:t>Done   Decoder built from scratch</a:t>
+              <a:t>Done:  Decoder written from scratch</a:t>
             </a:r>
           </a:p>
         </p:txBody>
@@ -13729,7 +13585,7 @@
                 </a:solidFill>
                 <a:latin typeface="Arial"/>
               </a:rPr>
-              <a:t>Done   M3: three parallel scans</a:t>
+              <a:t>Done:  M3 with 3 scan versions</a:t>
             </a:r>
           </a:p>
         </p:txBody>
@@ -13786,7 +13642,7 @@
                 </a:solidFill>
                 <a:latin typeface="Arial"/>
               </a:rPr>
-              <a:t>Done   M1: split-on-overflow</a:t>
+              <a:t>Done:  M1: splitting big chunks</a:t>
             </a:r>
           </a:p>
         </p:txBody>
@@ -13843,7 +13699,7 @@
                 </a:solidFill>
                 <a:latin typeface="Arial"/>
               </a:rPr>
-              <a:t>Done   Evaluation + rapidgzip comparison</a:t>
+              <a:t>Done:  Benchmarks + rapidgzip comparison</a:t>
             </a:r>
           </a:p>
         </p:txBody>
@@ -13898,7 +13754,7 @@
                 </a:solidFill>
                 <a:latin typeface="Arial"/>
               </a:rPr>
-              <a:t>Next   Streaming output; M3 inside rapidgzip</a:t>
+              <a:t>Next:  Streaming output, M3 in rapidgzip</a:t>
             </a:r>
           </a:p>
         </p:txBody>
@@ -13991,7 +13847,7 @@
                 </a:solidFill>
                 <a:latin typeface="Arial"/>
               </a:rPr>
-              <a:t>Chunk size (number of chunks). Hillis–Steele and Blelloch scans fall between the two; full table in the report.</a:t>
+              <a:t>Number of chunks in brackets. The Hillis-Steele and Blelloch scans land in between (table in the report).</a:t>
             </a:r>
           </a:p>
         </p:txBody>
@@ -14032,22 +13888,13 @@
               <a:buChar char="•"/>
             </a:pPr>
             <a:r>
-              <a:rPr sz="950" b="1" i="0">
-                <a:solidFill>
-                  <a:srgbClr val="212121"/>
+              <a:rPr sz="950" b="0" i="0">
+                <a:solidFill>
+                  <a:srgbClr val="595959"/>
                 </a:solidFill>
                 <a:latin typeface="Arial"/>
               </a:rPr>
-              <a:t>2.9–3.9× faster </a:t>
-            </a:r>
-            <a:r>
-              <a:rPr sz="950" b="0" i="0">
-                <a:solidFill>
-                  <a:srgbClr val="595959"/>
-                </a:solidFill>
-                <a:latin typeface="Arial"/>
-              </a:rPr>
-              <a:t>window step at every chunk size, p &lt; 0.001 (Mann–Whitney, Holm).</a:t>
+              <a:t>The scan is 2.9-3.9x faster than the one-by-one chain at every chunk size (p &lt; 0.001).</a:t>
             </a:r>
           </a:p>
           <a:p>
@@ -14065,22 +13912,13 @@
               <a:buChar char="•"/>
             </a:pPr>
             <a:r>
-              <a:rPr sz="950" b="1" i="0">
-                <a:solidFill>
-                  <a:srgbClr val="212121"/>
+              <a:rPr sz="950" b="0" i="0">
+                <a:solidFill>
+                  <a:srgbClr val="595959"/>
                 </a:solidFill>
                 <a:latin typeface="Arial"/>
               </a:rPr>
-              <a:t>Whole run, 64 KiB chunks: </a:t>
-            </a:r>
-            <a:r>
-              <a:rPr sz="950" b="0" i="0">
-                <a:solidFill>
-                  <a:srgbClr val="595959"/>
-                </a:solidFill>
-                <a:latin typeface="Arial"/>
-              </a:rPr>
-              <a:t>1.14× on Silesia ×5, 1.21× on Silesia; the chain was a fifth of the run.</a:t>
+              <a:t>With 64 KiB chunks the chain was about 20% of the run, so the whole decompression got 1.14x (Silesia x5) and 1.21x (Silesia) faster.</a:t>
             </a:r>
           </a:p>
           <a:p>
@@ -14098,22 +13936,13 @@
               <a:buChar char="•"/>
             </a:pPr>
             <a:r>
-              <a:rPr sz="950" b="1" i="0">
-                <a:solidFill>
-                  <a:srgbClr val="212121"/>
+              <a:rPr sz="950" b="0" i="0">
+                <a:solidFill>
+                  <a:srgbClr val="595959"/>
                 </a:solidFill>
                 <a:latin typeface="Arial"/>
               </a:rPr>
-              <a:t>Scales with cores: </a:t>
-            </a:r>
-            <a:r>
-              <a:rPr sz="950" b="0" i="0">
-                <a:solidFill>
-                  <a:srgbClr val="595959"/>
-                </a:solidFill>
-                <a:latin typeface="Arial"/>
-              </a:rPr>
-              <a:t>serial chain stays at 183–261 ms; the scan falls from 221 ms (2 threads) to 74 ms (10).</a:t>
+              <a:t>More threads help the scan (221 ms at 2 threads, 74 ms at 10). The chain stays at 180-260 ms.</a:t>
             </a:r>
           </a:p>
           <a:p>
@@ -14131,22 +13960,13 @@
               <a:buChar char="•"/>
             </a:pPr>
             <a:r>
-              <a:rPr sz="950" b="1" i="0">
-                <a:solidFill>
-                  <a:srgbClr val="212121"/>
+              <a:rPr sz="950" b="0" i="0">
+                <a:solidFill>
+                  <a:srgbClr val="595959"/>
                 </a:solidFill>
                 <a:latin typeface="Arial"/>
               </a:rPr>
-              <a:t>Why small chunks: </a:t>
-            </a:r>
-            <a:r>
-              <a:rPr sz="950" b="0" i="0">
-                <a:solidFill>
-                  <a:srgbClr val="595959"/>
-                </a:solidFill>
-                <a:latin typeface="Arial"/>
-              </a:rPr>
-              <a:t>512 KiB chunks need 19–35% less memory than 4 MiB; M3 removes their window-chain cost.</a:t>
+              <a:t>Small chunks use 19-35% less memory, which is why this is worth doing.</a:t>
             </a:r>
           </a:p>
           <a:p>
@@ -14170,7 +13990,7 @@
                 </a:solidFill>
                 <a:latin typeface="Arial"/>
               </a:rPr>
-              <a:t>Limits: </a:t>
+              <a:t>But </a:t>
             </a:r>
             <a:r>
               <a:rPr sz="950" b="0" i="0">
@@ -14179,7 +13999,7 @@
                 </a:solidFill>
                 <a:latin typeface="Arial"/>
               </a:rPr>
-              <a:t>from 1 MiB up the chain is under 2% of the run; at 64 KiB rapidgzip is still 1.3× faster than us (our other per-chunk costs are higher).</a:t>
+              <a:t>from 1 MiB up the chain is under 2% of the run, so there's no visible gain. And with 64 KiB chunks rapidgzip is still 1.3x faster than our whole decoder.</a:t>
             </a:r>
           </a:p>
         </p:txBody>
@@ -14254,7 +14074,7 @@
                 </a:solidFill>
                 <a:latin typeface="Arial"/>
               </a:rPr>
-              <a:t>Split-on-overflow, logs, 16 MiB chunks, 4× budget</a:t>
+              <a:t>Splitting big chunks (logs, 16 MiB chunks, 4x budget)</a:t>
             </a:r>
           </a:p>
         </p:txBody>
@@ -14295,7 +14115,7 @@
                           </a:solidFill>
                           <a:latin typeface="Arial"/>
                         </a:rPr>
-                        <a:t>Overflow policy</a:t>
+                        <a:t>Policy</a:t>
                       </a:r>
                     </a:p>
                   </a:txBody>
@@ -14341,7 +14161,7 @@
                           </a:solidFill>
                           <a:latin typeface="Arial"/>
                         </a:rPr>
-                        <a:t>λ</a:t>
+                        <a:t>Imbalance λ</a:t>
                       </a:r>
                     </a:p>
                   </a:txBody>
@@ -14389,7 +14209,7 @@
                           </a:solidFill>
                           <a:latin typeface="Arial"/>
                         </a:rPr>
-                        <a:t>Serial (base paper)</a:t>
+                        <a:t>One thread (rapidgzip)</a:t>
                       </a:r>
                     </a:p>
                   </a:txBody>
@@ -14552,7 +14372,7 @@
                           </a:solidFill>
                           <a:latin typeface="Arial"/>
                         </a:rPr>
-                        <a:t>1.59×</a:t>
+                        <a:t>1.59x</a:t>
                       </a:r>
                     </a:p>
                   </a:txBody>
@@ -14603,22 +14423,13 @@
               <a:buChar char="•"/>
             </a:pPr>
             <a:r>
-              <a:rPr sz="900" b="1" i="0">
-                <a:solidFill>
-                  <a:srgbClr val="212121"/>
+              <a:rPr sz="900" b="0" i="0">
+                <a:solidFill>
+                  <a:srgbClr val="595959"/>
                 </a:solidFill>
                 <a:latin typeface="Arial"/>
               </a:rPr>
-              <a:t>Matters when chunks are few: </a:t>
-            </a:r>
-            <a:r>
-              <a:rPr sz="900" b="0" i="0">
-                <a:solidFill>
-                  <a:srgbClr val="595959"/>
-                </a:solidFill>
-                <a:latin typeface="Arial"/>
-              </a:rPr>
-              <a:t>with 4 MiB chunks the difference is not significant.</a:t>
+              <a:t>This only helps when there are few chunks per thread. With 4 MiB chunks the difference isn't significant.</a:t>
             </a:r>
           </a:p>
           <a:p>
@@ -14636,22 +14447,13 @@
               <a:buChar char="•"/>
             </a:pPr>
             <a:r>
-              <a:rPr sz="900" b="1" i="0">
-                <a:solidFill>
-                  <a:srgbClr val="212121"/>
+              <a:rPr sz="900" b="0" i="0">
+                <a:solidFill>
+                  <a:srgbClr val="595959"/>
                 </a:solidFill>
                 <a:latin typeface="Arial"/>
               </a:rPr>
-              <a:t>Negative result: </a:t>
-            </a:r>
-            <a:r>
-              <a:rPr sz="900" b="0" i="0">
-                <a:solidFill>
-                  <a:srgbClr val="595959"/>
-                </a:solidFill>
-                <a:latin typeface="Arial"/>
-              </a:rPr>
-              <a:t>work-balanced chunking costs 10–74 ms of sampling and does not speed up decoding.</a:t>
+              <a:t>Sizing chunks from the Huffman headers (work-balanced chunking) didn't work out: sampling costs 10-74 ms and decoding isn't faster.</a:t>
             </a:r>
           </a:p>
         </p:txBody>
@@ -14686,7 +14488,7 @@
                 </a:solidFill>
                 <a:latin typeface="Arial"/>
               </a:rPr>
-              <a:t>Against rapidgzip 0.16.0, same machine (GB/s)</a:t>
+              <a:t>vs rapidgzip 0.16.0 on the same laptop (GB/s)</a:t>
             </a:r>
           </a:p>
         </p:txBody>
@@ -14751,7 +14553,7 @@
                           </a:solidFill>
                           <a:latin typeface="Arial"/>
                         </a:rPr>
-                        <a:t>Riptide 10t</a:t>
+                        <a:t>Ours, 10t</a:t>
                       </a:r>
                     </a:p>
                   </a:txBody>
@@ -14774,7 +14576,7 @@
                           </a:solidFill>
                           <a:latin typeface="Arial"/>
                         </a:rPr>
-                        <a:t>rapidgzip 10t</a:t>
+                        <a:t>rapidgzip, 10t</a:t>
                       </a:r>
                     </a:p>
                   </a:txBody>
@@ -14797,7 +14599,7 @@
                           </a:solidFill>
                           <a:latin typeface="Arial"/>
                         </a:rPr>
-                        <a:t>Riptide 1t</a:t>
+                        <a:t>Ours, 1t</a:t>
                       </a:r>
                     </a:p>
                   </a:txBody>
@@ -14820,7 +14622,7 @@
                           </a:solidFill>
                           <a:latin typeface="Arial"/>
                         </a:rPr>
-                        <a:t>rapidgzip 1t</a:t>
+                        <a:t>rapidgzip, 1t</a:t>
                       </a:r>
                     </a:p>
                   </a:txBody>
@@ -14962,7 +14764,7 @@
                           </a:solidFill>
                           <a:latin typeface="Arial"/>
                         </a:rPr>
-                        <a:t>Silesia ×5</a:t>
+                        <a:t>Silesia x5</a:t>
                       </a:r>
                     </a:p>
                   </a:txBody>
@@ -15333,7 +15135,7 @@
                 </a:solidFill>
                 <a:latin typeface="Arial"/>
               </a:rPr>
-              <a:t>10 threads: no significant difference (0.91–1.16×). 1–2 threads: Riptide 1.2–1.9× faster (rapidgzip has no ISA-L on ARM). rapidgzip needs 2–5× less memory and is 1.3× faster with 64 KiB chunks.</a:t>
+              <a:t>At 10 threads the difference isn't significant. With 1-2 threads we're 1.2-1.9x faster (their ARM build doesn't use ISA-L). rapidgzip uses 2-5x less memory and is 1.3x faster with 64 KiB chunks.</a:t>
             </a:r>
           </a:p>
         </p:txBody>
@@ -15400,7 +15202,7 @@
                 </a:solidFill>
                 <a:latin typeface="Arial"/>
               </a:rPr>
-              <a:t>Correctness gates every result: 1 200 of 1 200 runs byte-identical to zlib.</a:t>
+              <a:t>Correctness comes first: every one of the 1,200 runs matched zlib.</a:t>
             </a:r>
           </a:p>
           <a:p>
@@ -15412,7 +15214,7 @@
                 </a:solidFill>
                 <a:latin typeface="Arial"/>
               </a:rPr>
-              <a:t>Each contribution has its own metric: window-resolution time for M3, load imbalance λ for M1, peak memory per output byte.</a:t>
+              <a:t>Each idea has its own measure: time of the window step for M3, load imbalance λ for M1, and peak memory.</a:t>
             </a:r>
           </a:p>
           <a:p>
@@ -15424,7 +15226,7 @@
                 </a:solidFill>
                 <a:latin typeface="Arial"/>
               </a:rPr>
-              <a:t>Medians of 10 interleaved runs, Mann–Whitney U with Holm correction; one machine and three synthetic datasets are stated limits.</a:t>
+              <a:t>Every setting was run 10 times and compared with a Mann-Whitney U test (Holm correction). Limits: one laptop, and 3 of the 5 datasets are synthetic.</a:t>
             </a:r>
           </a:p>
         </p:txBody>

</xml_diff>